<commit_message>
chore: adiciona arquivos .gitignore e atualiza o README de setup do projeto
- Cria um .gitignore na raiz e outro em projeto-final-ia-suporte-sla para ignorar arquivos desnecessários.
- Atualiza o README.md com um guia passo a passo para configurar o ambiente e executar o pipeline, incluindo Airflow e Docker.
- Revisa as descrições dos modelos de machine learning e as métricas no README para maior clareza e precisão.
</commit_message>
<xml_diff>
--- a/projeto-final-ia-suporte-sla/docs/Apresentacao_Projeto_Final.pptx
+++ b/projeto-final-ia-suporte-sla/docs/Apresentacao_Projeto_Final.pptx
@@ -6013,7 +6013,7 @@
                 </a:solidFill>
                 <a:latin typeface="Calibri"/>
               </a:rPr>
-              <a:t>KNN (hard-code + biblioteca), SVM e MLP</a:t>
+              <a:t>Baselines, KNN (hard-code + biblioteca) e MLP</a:t>
             </a:r>
           </a:p>
         </p:txBody>
@@ -6028,7 +6028,7 @@
         </p:nvGraphicFramePr>
         <p:xfrm>
           <a:off x="548640" y="1783080"/>
-          <a:ext cx="6035040" cy="2514600"/>
+          <a:ext cx="6035040" cy="2194560"/>
         </p:xfrm>
         <a:graphic>
           <a:graphicData uri="http://schemas.openxmlformats.org/drawingml/2006/table">
@@ -6044,7 +6044,7 @@
                 <a:gridCol w="822960"/>
                 <a:gridCol w="822960"/>
               </a:tblGrid>
-              <a:tr h="419100">
+              <a:tr h="438912">
                 <a:tc>
                   <a:txBody>
                     <a:bodyPr/>
@@ -6172,7 +6172,7 @@
                   </a:tcPr>
                 </a:tc>
               </a:tr>
-              <a:tr h="419100">
+              <a:tr h="438912">
                 <a:tc>
                   <a:txBody>
                     <a:bodyPr/>
@@ -6197,7 +6197,7 @@
                     <a:p>
                       <a:r>
                         <a:rPr sz="1100" b="0"/>
-                        <a:t>0.771</a:t>
+                        <a:t>0,771</a:t>
                       </a:r>
                     </a:p>
                   </a:txBody>
@@ -6214,7 +6214,7 @@
                     <a:p>
                       <a:r>
                         <a:rPr sz="1100" b="0"/>
-                        <a:t>0.498</a:t>
+                        <a:t>0,498</a:t>
                       </a:r>
                     </a:p>
                   </a:txBody>
@@ -6231,7 +6231,7 @@
                     <a:p>
                       <a:r>
                         <a:rPr sz="1100" b="0"/>
-                        <a:t>0.629</a:t>
+                        <a:t>0,629</a:t>
                       </a:r>
                     </a:p>
                   </a:txBody>
@@ -6248,7 +6248,7 @@
                     <a:p>
                       <a:r>
                         <a:rPr sz="1100" b="0"/>
-                        <a:t>0.556</a:t>
+                        <a:t>0,556</a:t>
                       </a:r>
                     </a:p>
                   </a:txBody>
@@ -6265,7 +6265,7 @@
                     <a:p>
                       <a:r>
                         <a:rPr sz="1100" b="0"/>
-                        <a:t>0.721</a:t>
+                        <a:t>0,721</a:t>
                       </a:r>
                     </a:p>
                   </a:txBody>
@@ -6276,7 +6276,7 @@
                   </a:tcPr>
                 </a:tc>
               </a:tr>
-              <a:tr h="419100">
+              <a:tr h="438912">
                 <a:tc>
                   <a:txBody>
                     <a:bodyPr/>
@@ -6301,7 +6301,7 @@
                     <a:p>
                       <a:r>
                         <a:rPr sz="1100" b="0"/>
-                        <a:t>0.838</a:t>
+                        <a:t>0,838</a:t>
                       </a:r>
                     </a:p>
                   </a:txBody>
@@ -6318,7 +6318,7 @@
                     <a:p>
                       <a:r>
                         <a:rPr sz="1100" b="0"/>
-                        <a:t>0.762</a:t>
+                        <a:t>0,762</a:t>
                       </a:r>
                     </a:p>
                   </a:txBody>
@@ -6335,7 +6335,7 @@
                     <a:p>
                       <a:r>
                         <a:rPr sz="1100" b="0"/>
-                        <a:t>0.421</a:t>
+                        <a:t>0,421</a:t>
                       </a:r>
                     </a:p>
                   </a:txBody>
@@ -6352,7 +6352,7 @@
                     <a:p>
                       <a:r>
                         <a:rPr sz="1100" b="0"/>
-                        <a:t>0.542</a:t>
+                        <a:t>0,542</a:t>
                       </a:r>
                     </a:p>
                   </a:txBody>
@@ -6369,7 +6369,7 @@
                     <a:p>
                       <a:r>
                         <a:rPr sz="1100" b="0"/>
-                        <a:t>0.882</a:t>
+                        <a:t>0,882</a:t>
                       </a:r>
                     </a:p>
                   </a:txBody>
@@ -6380,7 +6380,7 @@
                   </a:tcPr>
                 </a:tc>
               </a:tr>
-              <a:tr h="419100">
+              <a:tr h="438912">
                 <a:tc>
                   <a:txBody>
                     <a:bodyPr/>
@@ -6405,7 +6405,7 @@
                     <a:p>
                       <a:r>
                         <a:rPr sz="1100" b="0"/>
-                        <a:t>0.838</a:t>
+                        <a:t>0,838</a:t>
                       </a:r>
                     </a:p>
                   </a:txBody>
@@ -6422,7 +6422,7 @@
                     <a:p>
                       <a:r>
                         <a:rPr sz="1100" b="0"/>
-                        <a:t>0.762</a:t>
+                        <a:t>0,762</a:t>
                       </a:r>
                     </a:p>
                   </a:txBody>
@@ -6439,7 +6439,7 @@
                     <a:p>
                       <a:r>
                         <a:rPr sz="1100" b="0"/>
-                        <a:t>0.421</a:t>
+                        <a:t>0,421</a:t>
                       </a:r>
                     </a:p>
                   </a:txBody>
@@ -6456,7 +6456,7 @@
                     <a:p>
                       <a:r>
                         <a:rPr sz="1100" b="0"/>
-                        <a:t>0.542</a:t>
+                        <a:t>0,542</a:t>
                       </a:r>
                     </a:p>
                   </a:txBody>
@@ -6473,7 +6473,7 @@
                     <a:p>
                       <a:r>
                         <a:rPr sz="1100" b="0"/>
-                        <a:t>0.882</a:t>
+                        <a:t>0,882</a:t>
                       </a:r>
                     </a:p>
                   </a:txBody>
@@ -6484,7 +6484,7 @@
                   </a:tcPr>
                 </a:tc>
               </a:tr>
-              <a:tr h="419100">
+              <a:tr h="438912">
                 <a:tc>
                   <a:txBody>
                     <a:bodyPr/>
@@ -6492,7 +6492,7 @@
                     <a:p>
                       <a:r>
                         <a:rPr sz="1100" b="1"/>
-                        <a:t>SVM *</a:t>
+                        <a:t>MLP *</a:t>
                       </a:r>
                     </a:p>
                   </a:txBody>
@@ -6509,7 +6509,7 @@
                     <a:p>
                       <a:r>
                         <a:rPr sz="1100" b="1"/>
-                        <a:t>0.903</a:t>
+                        <a:t>0,887</a:t>
                       </a:r>
                     </a:p>
                   </a:txBody>
@@ -6526,7 +6526,7 @@
                     <a:p>
                       <a:r>
                         <a:rPr sz="1100" b="1"/>
-                        <a:t>0.854</a:t>
+                        <a:t>0,747</a:t>
                       </a:r>
                     </a:p>
                   </a:txBody>
@@ -6543,7 +6543,7 @@
                     <a:p>
                       <a:r>
                         <a:rPr sz="1100" b="1"/>
-                        <a:t>0.693</a:t>
+                        <a:t>0,765</a:t>
                       </a:r>
                     </a:p>
                   </a:txBody>
@@ -6560,7 +6560,7 @@
                     <a:p>
                       <a:r>
                         <a:rPr sz="1100" b="1"/>
-                        <a:t>0.765</a:t>
+                        <a:t>0,756</a:t>
                       </a:r>
                     </a:p>
                   </a:txBody>
@@ -6577,117 +6577,13 @@
                     <a:p>
                       <a:r>
                         <a:rPr sz="1100" b="1"/>
-                        <a:t>0.953</a:t>
+                        <a:t>0,944</a:t>
                       </a:r>
                     </a:p>
                   </a:txBody>
                   <a:tcPr>
                     <a:solidFill>
                       <a:srgbClr val="E6F7F4"/>
-                    </a:solidFill>
-                  </a:tcPr>
-                </a:tc>
-              </a:tr>
-              <a:tr h="419100">
-                <a:tc>
-                  <a:txBody>
-                    <a:bodyPr/>
-                    <a:lstStyle/>
-                    <a:p>
-                      <a:r>
-                        <a:rPr sz="1100" b="0"/>
-                        <a:t>MLP</a:t>
-                      </a:r>
-                    </a:p>
-                  </a:txBody>
-                  <a:tcPr>
-                    <a:solidFill>
-                      <a:srgbClr val="F2F4F8"/>
-                    </a:solidFill>
-                  </a:tcPr>
-                </a:tc>
-                <a:tc>
-                  <a:txBody>
-                    <a:bodyPr/>
-                    <a:lstStyle/>
-                    <a:p>
-                      <a:r>
-                        <a:rPr sz="1100" b="0"/>
-                        <a:t>0.887</a:t>
-                      </a:r>
-                    </a:p>
-                  </a:txBody>
-                  <a:tcPr>
-                    <a:solidFill>
-                      <a:srgbClr val="F2F4F8"/>
-                    </a:solidFill>
-                  </a:tcPr>
-                </a:tc>
-                <a:tc>
-                  <a:txBody>
-                    <a:bodyPr/>
-                    <a:lstStyle/>
-                    <a:p>
-                      <a:r>
-                        <a:rPr sz="1100" b="0"/>
-                        <a:t>0.747</a:t>
-                      </a:r>
-                    </a:p>
-                  </a:txBody>
-                  <a:tcPr>
-                    <a:solidFill>
-                      <a:srgbClr val="F2F4F8"/>
-                    </a:solidFill>
-                  </a:tcPr>
-                </a:tc>
-                <a:tc>
-                  <a:txBody>
-                    <a:bodyPr/>
-                    <a:lstStyle/>
-                    <a:p>
-                      <a:r>
-                        <a:rPr sz="1100" b="0"/>
-                        <a:t>0.765</a:t>
-                      </a:r>
-                    </a:p>
-                  </a:txBody>
-                  <a:tcPr>
-                    <a:solidFill>
-                      <a:srgbClr val="F2F4F8"/>
-                    </a:solidFill>
-                  </a:tcPr>
-                </a:tc>
-                <a:tc>
-                  <a:txBody>
-                    <a:bodyPr/>
-                    <a:lstStyle/>
-                    <a:p>
-                      <a:r>
-                        <a:rPr sz="1100" b="0"/>
-                        <a:t>0.756</a:t>
-                      </a:r>
-                    </a:p>
-                  </a:txBody>
-                  <a:tcPr>
-                    <a:solidFill>
-                      <a:srgbClr val="F2F4F8"/>
-                    </a:solidFill>
-                  </a:tcPr>
-                </a:tc>
-                <a:tc>
-                  <a:txBody>
-                    <a:bodyPr/>
-                    <a:lstStyle/>
-                    <a:p>
-                      <a:r>
-                        <a:rPr sz="1100" b="0"/>
-                        <a:t>0.944</a:t>
-                      </a:r>
-                    </a:p>
-                  </a:txBody>
-                  <a:tcPr>
-                    <a:solidFill>
-                      <a:srgbClr val="F2F4F8"/>
                     </a:solidFill>
                   </a:tcPr>
                 </a:tc>
@@ -6916,7 +6812,7 @@
                 </a:solidFill>
                 <a:latin typeface="Calibri"/>
               </a:rPr>
-              <a:t>• SVM teve o melhor F1 (0,77) e AUC (0,95), sendo escolhido como modelo de produção.</a:t>
+              <a:t>• O MLP teve o melhor F1 (0,756) e recall (0,765), sendo escolhido como modelo de produção.</a:t>
             </a:r>
           </a:p>
         </p:txBody>

</xml_diff>